<commit_message>
Module 4 (Scripting): expand to Bash + Python at full depth
- README: full Bash section (shebang, vars, read, conditions, loops, Ping Sweep
  project) + full Python (types, structures, functions, socket, Port Scanner)
  + Bash-vs-Python comparison
- missions.md: graded Bash+Python exercises + scanner-upgrade capstone
- solutions.md: NEW full step-by-step solutions incl. complete upgraded scanner
- slides.md: expanded to cover both languages

Co-Authored-By: Claude Opus 4.8 <noreply@anthropic.com>
Claude-Session: https://claude.ai/code/session_01Ghjnb4wipnzRi4CSLijMVc
</commit_message>
<xml_diff>
--- a/dist/slides-pptx/04-scripting-bash-python.pptx
+++ b/dist/slides-pptx/04-scripting-bash-python.pptx
@@ -15,6 +15,8 @@
     <p:sldId id="263" r:id="rId9"/>
     <p:sldId id="264" r:id="rId10"/>
     <p:sldId id="265" r:id="rId11"/>
+    <p:sldId id="266" r:id="rId12"/>
+    <p:sldId id="267" r:id="rId13"/>
   </p:sldIdLst>
   <p:sldSz cx="9144000" cy="5143500" type="screen16x9"/>
   <p:notesSz cx="6858000" cy="9144000"/>
@@ -3173,7 +3175,7 @@
             </a:pPr>
             <a:r>
               <a:rPr/>
-              <a:t>Python להאקרים</a:t>
+              <a:t>סקריפטינג: Bash ו-Python</a:t>
             </a:r>
           </a:p>
         </p:txBody>
@@ -3220,7 +3222,7 @@
             </a:pPr>
             <a:r>
               <a:rPr/>
-              <a:t>סיכום מודול 4</a:t>
+              <a:t>פרויקט Python — Port Scanner</a:t>
             </a:r>
           </a:p>
         </p:txBody>
@@ -3242,22 +3244,145 @@
           <a:p>
             <a:pPr lvl="0" algn="r" rtl="1"/>
             <a:r>
-              <a:rPr/>
-              <a:t>טיפוסים, מבני נתונים, לולאות ופונקציות</a:t>
-            </a:r>
-          </a:p>
-          <a:p>
-            <a:pPr lvl="0" algn="r" rtl="1"/>
-            <a:r>
-              <a:rPr/>
-              <a:t>socket = יכולות רשת</a:t>
-            </a:r>
-          </a:p>
-          <a:p>
-            <a:pPr lvl="0" algn="r" rtl="1"/>
-            <a:r>
-              <a:rPr/>
-              <a:t>בנינו סורק פורטים אמיתי</a:t>
+              <a:rPr>
+                <a:latin typeface="Courier"/>
+              </a:rPr>
+              <a:t>socket(AF_INET, SOCK_STREAM)</a:t>
+            </a:r>
+            <a:r>
+              <a:rPr/>
+              <a:t> — TCP</a:t>
+            </a:r>
+          </a:p>
+          <a:p>
+            <a:pPr lvl="0" algn="r" rtl="1"/>
+            <a:r>
+              <a:rPr>
+                <a:latin typeface="Courier"/>
+              </a:rPr>
+              <a:t>settimeout(0.5)</a:t>
+            </a:r>
+            <a:r>
+              <a:rPr/>
+              <a:t> — לא להיתקע</a:t>
+            </a:r>
+          </a:p>
+          <a:p>
+            <a:pPr lvl="0" algn="r" rtl="1"/>
+            <a:r>
+              <a:rPr>
+                <a:latin typeface="Courier"/>
+              </a:rPr>
+              <a:t>connect_ex()</a:t>
+            </a:r>
+            <a:r>
+              <a:rPr/>
+              <a:t> == 0 → פורט פתוח</a:t>
+            </a:r>
+          </a:p>
+          <a:p>
+            <a:pPr lvl="0" algn="r" rtl="1"/>
+            <a:r>
+              <a:rPr>
+                <a:latin typeface="Courier"/>
+              </a:rPr>
+              <a:t>try/except</a:t>
+            </a:r>
+            <a:r>
+              <a:rPr/>
+              <a:t> ל-Ctrl+C ולשגיאות DNS</a:t>
+            </a:r>
+          </a:p>
+        </p:txBody>
+      </p:sp>
+    </p:spTree>
+  </p:cSld>
+</p:sld>
+</file>
+
+<file path=ppt/slides/slide11.xml><?xml version="1.0" encoding="utf-8"?>
+<p:sld xmlns:a="http://schemas.openxmlformats.org/drawingml/2006/main" xmlns:r="http://schemas.openxmlformats.org/officeDocument/2006/relationships" xmlns:p="http://schemas.openxmlformats.org/presentationml/2006/main">
+  <p:cSld>
+    <p:spTree>
+      <p:nvGrpSpPr>
+        <p:cNvPr id="1" name=""/>
+        <p:cNvGrpSpPr/>
+        <p:nvPr/>
+      </p:nvGrpSpPr>
+      <p:grpSpPr>
+        <a:xfrm>
+          <a:off x="0" y="0"/>
+          <a:ext cx="0" cy="0"/>
+          <a:chOff x="0" y="0"/>
+          <a:chExt cx="0" cy="0"/>
+        </a:xfrm>
+      </p:grpSpPr>
+      <p:sp>
+        <p:nvSpPr>
+          <p:cNvPr id="2" name="Title 1"/>
+          <p:cNvSpPr>
+            <a:spLocks noGrp="1"/>
+          </p:cNvSpPr>
+          <p:nvPr>
+            <p:ph type="title"/>
+          </p:nvPr>
+        </p:nvSpPr>
+        <p:spPr/>
+        <p:txBody>
+          <a:bodyPr/>
+          <a:lstStyle/>
+          <a:p>
+            <a:pPr marL="0" lvl="0" indent="0" algn="r" rtl="1">
+              <a:buNone/>
+            </a:pPr>
+            <a:r>
+              <a:rPr/>
+              <a:t>Bash מול Python — מתי מה?</a:t>
+            </a:r>
+          </a:p>
+        </p:txBody>
+      </p:sp>
+      <p:sp>
+        <p:nvSpPr>
+          <p:cNvPr id="3" name="Content Placeholder 2"/>
+          <p:cNvSpPr>
+            <a:spLocks noGrp="1"/>
+          </p:cNvSpPr>
+          <p:nvPr>
+            <p:ph idx="1"/>
+          </p:nvPr>
+        </p:nvSpPr>
+        <p:spPr/>
+        <p:txBody>
+          <a:bodyPr/>
+          <a:lstStyle/>
+          <a:p>
+            <a:pPr lvl="0" algn="r" rtl="1"/>
+            <a:r>
+              <a:rPr b="1"/>
+              <a:t>Bash</a:t>
+            </a:r>
+            <a:r>
+              <a:rPr/>
+              <a:t> — one-liners, שרשור כלים, מערכת</a:t>
+            </a:r>
+          </a:p>
+          <a:p>
+            <a:pPr lvl="0" algn="r" rtl="1"/>
+            <a:r>
+              <a:rPr b="1"/>
+              <a:t>Python</a:t>
+            </a:r>
+            <a:r>
+              <a:rPr/>
+              <a:t> — כלים גדולים, רשת, לוגיקה</a:t>
+            </a:r>
+          </a:p>
+          <a:p>
+            <a:pPr lvl="0" algn="r" rtl="1"/>
+            <a:r>
+              <a:rPr/>
+              <a:t>Bash “מדביק” · Python “בונה”</a:t>
             </a:r>
           </a:p>
           <a:p>
@@ -3274,18 +3399,126 @@
             </a:r>
             <a:r>
               <a:rPr/>
-              <a:t> או המעבדה</a:t>
+              <a:t>/המעבדה</a:t>
+            </a:r>
+          </a:p>
+        </p:txBody>
+      </p:sp>
+    </p:spTree>
+  </p:cSld>
+</p:sld>
+</file>
+
+<file path=ppt/slides/slide12.xml><?xml version="1.0" encoding="utf-8"?>
+<p:sld xmlns:a="http://schemas.openxmlformats.org/drawingml/2006/main" xmlns:r="http://schemas.openxmlformats.org/officeDocument/2006/relationships" xmlns:p="http://schemas.openxmlformats.org/presentationml/2006/main">
+  <p:cSld>
+    <p:spTree>
+      <p:nvGrpSpPr>
+        <p:cNvPr id="1" name=""/>
+        <p:cNvGrpSpPr/>
+        <p:nvPr/>
+      </p:nvGrpSpPr>
+      <p:grpSpPr>
+        <a:xfrm>
+          <a:off x="0" y="0"/>
+          <a:ext cx="0" cy="0"/>
+          <a:chOff x="0" y="0"/>
+          <a:chExt cx="0" cy="0"/>
+        </a:xfrm>
+      </p:grpSpPr>
+      <p:sp>
+        <p:nvSpPr>
+          <p:cNvPr id="2" name="Title 1"/>
+          <p:cNvSpPr>
+            <a:spLocks noGrp="1"/>
+          </p:cNvSpPr>
+          <p:nvPr>
+            <p:ph type="title"/>
+          </p:nvPr>
+        </p:nvSpPr>
+        <p:spPr/>
+        <p:txBody>
+          <a:bodyPr/>
+          <a:lstStyle/>
+          <a:p>
+            <a:pPr marL="0" lvl="0" indent="0" algn="r" rtl="1">
+              <a:buNone/>
+            </a:pPr>
+            <a:r>
+              <a:rPr/>
+              <a:t>סיכום מודול 4</a:t>
+            </a:r>
+          </a:p>
+        </p:txBody>
+      </p:sp>
+      <p:sp>
+        <p:nvSpPr>
+          <p:cNvPr id="3" name="Content Placeholder 2"/>
+          <p:cNvSpPr>
+            <a:spLocks noGrp="1"/>
+          </p:cNvSpPr>
+          <p:nvPr>
+            <p:ph idx="1"/>
+          </p:nvPr>
+        </p:nvSpPr>
+        <p:spPr/>
+        <p:txBody>
+          <a:bodyPr/>
+          <a:lstStyle/>
+          <a:p>
+            <a:pPr lvl="0" algn="r" rtl="1"/>
+            <a:r>
+              <a:rPr/>
+              <a:t>Bash: Shebang, משתנים, תנאים, לולאות → Ping Sweep</a:t>
+            </a:r>
+          </a:p>
+          <a:p>
+            <a:pPr lvl="0" algn="r" rtl="1"/>
+            <a:r>
+              <a:rPr/>
+              <a:t>Python: טיפוסים, מבנים, פונקציות → Port Scanner</a:t>
+            </a:r>
+          </a:p>
+          <a:p>
+            <a:pPr lvl="0" algn="r" rtl="1"/>
+            <a:r>
+              <a:rPr/>
+              <a:t>שני כלים אמיתיים ביד</a:t>
             </a:r>
           </a:p>
           <a:p>
             <a:pPr lvl="0" algn="r" rtl="1"/>
             <a:r>
               <a:rPr b="1"/>
-              <a:t>תרגול:</a:t>
-            </a:r>
-            <a:r>
-              <a:rPr/>
-              <a:t> הוסף שמות שירות לפלט</a:t>
+              <a:t>תרגילים</a:t>
+            </a:r>
+            <a:r>
+              <a:rPr/>
+              <a:t> → </a:t>
+            </a:r>
+            <a:r>
+              <a:rPr>
+                <a:latin typeface="Courier"/>
+              </a:rPr>
+              <a:t>missions.md</a:t>
+            </a:r>
+            <a:r>
+              <a:rPr/>
+              <a:t> · </a:t>
+            </a:r>
+            <a:r>
+              <a:rPr b="1"/>
+              <a:t>פתרונות</a:t>
+            </a:r>
+            <a:r>
+              <a:rPr/>
+              <a:t> → </a:t>
+            </a:r>
+            <a:r>
+              <a:rPr>
+                <a:latin typeface="Courier"/>
+              </a:rPr>
+              <a:t>solutions.md</a:t>
             </a:r>
           </a:p>
         </p:txBody>
@@ -3332,7 +3565,7 @@
             </a:pPr>
             <a:r>
               <a:rPr/>
-              <a:t>מודול 4 — Scripting: Bash &amp; Python</a:t>
+              <a:t>מודול 4 — Scripting for Hackers</a:t>
             </a:r>
           </a:p>
         </p:txBody>
@@ -3355,28 +3588,28 @@
             <a:pPr lvl="0" algn="r" rtl="1"/>
             <a:r>
               <a:rPr/>
-              <a:t>יסודות: משתנים ומבני נתונים</a:t>
-            </a:r>
-          </a:p>
-          <a:p>
-            <a:pPr lvl="0" algn="r" rtl="1"/>
-            <a:r>
-              <a:rPr/>
-              <a:t>תנאים, לולאות, פונקציות</a:t>
-            </a:r>
-          </a:p>
-          <a:p>
-            <a:pPr lvl="0" algn="r" rtl="1"/>
-            <a:r>
-              <a:rPr/>
-              <a:t>מודולים ו-socket</a:t>
-            </a:r>
-          </a:p>
-          <a:p>
-            <a:pPr lvl="0" algn="r" rtl="1"/>
-            <a:r>
-              <a:rPr/>
-              <a:t>פרויקט: סורק פורטים</a:t>
+              <a:t>למה סקריפטינג? אוטומציה</a:t>
+            </a:r>
+          </a:p>
+          <a:p>
+            <a:pPr lvl="0" algn="r" rtl="1"/>
+            <a:r>
+              <a:rPr/>
+              <a:t>Bash — שפת ה-Terminal</a:t>
+            </a:r>
+          </a:p>
+          <a:p>
+            <a:pPr lvl="0" algn="r" rtl="1"/>
+            <a:r>
+              <a:rPr/>
+              <a:t>Python — שפת הכלים</a:t>
+            </a:r>
+          </a:p>
+          <a:p>
+            <a:pPr lvl="0" algn="r" rtl="1"/>
+            <a:r>
+              <a:rPr/>
+              <a:t>פרויקטים: Ping Sweep + Port Scanner</a:t>
             </a:r>
           </a:p>
         </p:txBody>
@@ -3423,7 +3656,7 @@
             </a:pPr>
             <a:r>
               <a:rPr/>
-              <a:t>למה Python?</a:t>
+              <a:t>למה סקריפטינג?</a:t>
             </a:r>
           </a:p>
         </p:txBody>
@@ -3446,14 +3679,29 @@
             <a:pPr lvl="0" algn="r" rtl="1"/>
             <a:r>
               <a:rPr/>
-              <a:t>השפה הנפוצה בכלי אבטחה ואוטומציה</a:t>
-            </a:r>
-          </a:p>
-          <a:p>
-            <a:pPr lvl="0" algn="r" rtl="1"/>
-            <a:r>
-              <a:rPr/>
-              <a:t>רוב ה-Exploits והסקריפטים כתובים בה</a:t>
+              <a:t>האקר לא מקליד פקודה 254 פעם — כותב לולאה</a:t>
+            </a:r>
+          </a:p>
+          <a:p>
+            <a:pPr lvl="0" algn="r" rtl="1"/>
+            <a:r>
+              <a:rPr b="1"/>
+              <a:t>Bash</a:t>
+            </a:r>
+            <a:r>
+              <a:rPr/>
+              <a:t> — אוטומציה של פקודות מערכת</a:t>
+            </a:r>
+          </a:p>
+          <a:p>
+            <a:pPr lvl="0" algn="r" rtl="1"/>
+            <a:r>
+              <a:rPr b="1"/>
+              <a:t>Python</a:t>
+            </a:r>
+            <a:r>
+              <a:rPr/>
+              <a:t> — כלים, Exploits, לוגיקה</a:t>
             </a:r>
           </a:p>
           <a:p>
@@ -3461,13 +3709,6 @@
             <a:r>
               <a:rPr/>
               <a:t>לא צריך להיות מתכנת</a:t>
-            </a:r>
-          </a:p>
-          <a:p>
-            <a:pPr lvl="0" algn="r" rtl="1"/>
-            <a:r>
-              <a:rPr/>
-              <a:t>מספיק לקרוא, לשנות ולכתוב סקריפטים</a:t>
             </a:r>
           </a:p>
         </p:txBody>
@@ -3514,7 +3755,7 @@
             </a:pPr>
             <a:r>
               <a:rPr/>
-              <a:t>משתנים וטיפוסים</a:t>
+              <a:t>Bash — מבנה בסיסי</a:t>
             </a:r>
           </a:p>
         </p:txBody>
@@ -3535,80 +3776,64 @@
           <a:lstStyle/>
           <a:p>
             <a:pPr lvl="0" algn="r" rtl="1"/>
-            <a:r>
-              <a:rPr b="1"/>
-              <a:t>String</a:t>
-            </a:r>
-            <a:r>
-              <a:rPr/>
-              <a:t> — טקסט: </a:t>
-            </a:r>
             <a:r>
               <a:rPr>
                 <a:latin typeface="Courier"/>
               </a:rPr>
-              <a:t>"nmap"</a:t>
-            </a:r>
-          </a:p>
-          <a:p>
-            <a:pPr lvl="0" algn="r" rtl="1"/>
-            <a:r>
-              <a:rPr b="1"/>
-              <a:t>Integer</a:t>
-            </a:r>
-            <a:r>
-              <a:rPr/>
-              <a:t> — מספר שלם: </a:t>
-            </a:r>
+              <a:t>#!/bin/bash</a:t>
+            </a:r>
+            <a:r>
+              <a:rPr/>
+              <a:t> — Shebang (חובה)</a:t>
+            </a:r>
+          </a:p>
+          <a:p>
+            <a:pPr lvl="0" algn="r" rtl="1"/>
             <a:r>
               <a:rPr>
                 <a:latin typeface="Courier"/>
               </a:rPr>
-              <a:t>443</a:t>
-            </a:r>
-          </a:p>
-          <a:p>
-            <a:pPr lvl="0" algn="r" rtl="1"/>
-            <a:r>
-              <a:rPr b="1"/>
-              <a:t>Float</a:t>
-            </a:r>
-            <a:r>
-              <a:rPr/>
-              <a:t> — עשרוני: </a:t>
-            </a:r>
+              <a:t>name="Kali"</a:t>
+            </a:r>
+            <a:r>
+              <a:rPr/>
+              <a:t> — משתנה (ללא רווחים!)</a:t>
+            </a:r>
+          </a:p>
+          <a:p>
+            <a:pPr lvl="0" algn="r" rtl="1"/>
             <a:r>
               <a:rPr>
                 <a:latin typeface="Courier"/>
               </a:rPr>
-              <a:t>2.5</a:t>
-            </a:r>
-          </a:p>
-          <a:p>
-            <a:pPr lvl="0" algn="r" rtl="1"/>
-            <a:r>
-              <a:rPr b="1"/>
-              <a:t>Boolean</a:t>
-            </a:r>
-            <a:r>
-              <a:rPr/>
-              <a:t> — </a:t>
+              <a:t>echo "$name"</a:t>
+            </a:r>
+            <a:r>
+              <a:rPr/>
+              <a:t> — שימוש</a:t>
+            </a:r>
+          </a:p>
+          <a:p>
+            <a:pPr lvl="0" algn="r" rtl="1"/>
+            <a:r>
+              <a:rPr/>
+              <a:t>הרצה: </a:t>
             </a:r>
             <a:r>
               <a:rPr>
                 <a:latin typeface="Courier"/>
               </a:rPr>
-              <a:t>True</a:t>
-            </a:r>
-            <a:r>
-              <a:rPr/>
-              <a:t> / </a:t>
+              <a:t>chmod +x</a:t>
+            </a:r>
+            <a:r>
+              <a:rPr/>
+              <a:t> ואז </a:t>
             </a:r>
             <a:r>
               <a:rPr>
                 <a:latin typeface="Courier"/>
               </a:rPr>
-              <a:t>False</a:t>
+              <a:t>./script.sh</a:t>
             </a:r>
           </a:p>
         </p:txBody>
@@ -3655,7 +3880,7 @@
             </a:pPr>
             <a:r>
               <a:rPr/>
-              <a:t>מבני נתונים</a:t>
+              <a:t>Bash — קלט, תנאים, לולאות</a:t>
             </a:r>
           </a:p>
         </p:txBody>
@@ -3676,78 +3901,46 @@
           <a:lstStyle/>
           <a:p>
             <a:pPr lvl="0" algn="r" rtl="1"/>
-            <a:r>
-              <a:rPr b="1"/>
-              <a:t>List</a:t>
-            </a:r>
-            <a:r>
-              <a:rPr/>
-              <a:t> </a:t>
-            </a:r>
             <a:r>
               <a:rPr>
                 <a:latin typeface="Courier"/>
               </a:rPr>
-              <a:t>[ ]</a:t>
-            </a:r>
-            <a:r>
-              <a:rPr/>
-              <a:t> — מסודר, משתנה</a:t>
-            </a:r>
-          </a:p>
-          <a:p>
-            <a:pPr lvl="0" algn="r" rtl="1"/>
-            <a:r>
-              <a:rPr b="1"/>
-              <a:t>Dictionary</a:t>
-            </a:r>
-            <a:r>
-              <a:rPr/>
-              <a:t> </a:t>
-            </a:r>
+              <a:t>read -p "IP: " ip</a:t>
+            </a:r>
+            <a:r>
+              <a:rPr/>
+              <a:t> — קלט</a:t>
+            </a:r>
+          </a:p>
+          <a:p>
+            <a:pPr lvl="0" algn="r" rtl="1"/>
             <a:r>
               <a:rPr>
                 <a:latin typeface="Courier"/>
               </a:rPr>
-              <a:t>{key: value}</a:t>
-            </a:r>
-            <a:r>
-              <a:rPr/>
-              <a:t> — מיפוי</a:t>
-            </a:r>
-          </a:p>
-          <a:p>
-            <a:pPr lvl="0" algn="r" rtl="1"/>
-            <a:r>
-              <a:rPr b="1"/>
-              <a:t>Tuple</a:t>
-            </a:r>
-            <a:r>
-              <a:rPr/>
-              <a:t> </a:t>
-            </a:r>
+              <a:t>$1 $2</a:t>
+            </a:r>
+            <a:r>
+              <a:rPr/>
+              <a:t> — ארגומנטים</a:t>
+            </a:r>
+          </a:p>
+          <a:p>
+            <a:pPr lvl="0" algn="r" rtl="1"/>
             <a:r>
               <a:rPr>
                 <a:latin typeface="Courier"/>
               </a:rPr>
-              <a:t>( )</a:t>
-            </a:r>
-            <a:r>
-              <a:rPr/>
-              <a:t> — קבוע</a:t>
-            </a:r>
-          </a:p>
-          <a:p>
-            <a:pPr lvl="0" algn="r" rtl="1"/>
-            <a:r>
-              <a:rPr/>
-              <a:t>דוגמה: </a:t>
-            </a:r>
+              <a:t>if [ "$port" -eq 80 ]; then ... fi</a:t>
+            </a:r>
+          </a:p>
+          <a:p>
+            <a:pPr lvl="0" algn="r" rtl="1"/>
             <a:r>
               <a:rPr>
                 <a:latin typeface="Courier"/>
               </a:rPr>
-              <a:t>services = {80: "HTTP"}</a:t>
+              <a:t>for i in $(seq 1 254); do ... done</a:t>
             </a:r>
           </a:p>
         </p:txBody>
@@ -3794,7 +3987,7 @@
             </a:pPr>
             <a:r>
               <a:rPr/>
-              <a:t>תנאים ולולאות</a:t>
+              <a:t>פרויקט Bash — Ping Sweep</a:t>
             </a:r>
           </a:p>
         </p:txBody>
@@ -3815,15 +4008,30 @@
           <a:lstStyle/>
           <a:p>
             <a:pPr lvl="0" algn="r" rtl="1"/>
+            <a:r>
+              <a:rPr/>
+              <a:t>מוצא מכונות </a:t>
+            </a:r>
+            <a:r>
+              <a:rPr b="1"/>
+              <a:t>חיות</a:t>
+            </a:r>
+            <a:r>
+              <a:rPr/>
+              <a:t> בתת-רשת (Host Discovery)</a:t>
+            </a:r>
+          </a:p>
+          <a:p>
+            <a:pPr lvl="0" algn="r" rtl="1"/>
+            <a:r>
+              <a:rPr/>
+              <a:t>לולאה על 1–254 + </a:t>
+            </a:r>
             <a:r>
               <a:rPr>
                 <a:latin typeface="Courier"/>
               </a:rPr>
-              <a:t>if / elif / else</a:t>
-            </a:r>
-            <a:r>
-              <a:rPr/>
-              <a:t> — קבלת החלטות</a:t>
+              <a:t>ping -c 1</a:t>
             </a:r>
           </a:p>
           <a:p>
@@ -3832,31 +4040,28 @@
               <a:rPr>
                 <a:latin typeface="Courier"/>
               </a:rPr>
-              <a:t>for port in range(1, 101)</a:t>
-            </a:r>
-            <a:r>
-              <a:rPr/>
-              <a:t> — טווח</a:t>
-            </a:r>
-          </a:p>
-          <a:p>
-            <a:pPr lvl="0" algn="r" rtl="1"/>
+              <a:t>&amp;</a:t>
+            </a:r>
+            <a:r>
+              <a:rPr/>
+              <a:t> להרצה מקבילה · </a:t>
+            </a:r>
             <a:r>
               <a:rPr>
                 <a:latin typeface="Courier"/>
               </a:rPr>
-              <a:t>while</a:t>
-            </a:r>
-            <a:r>
-              <a:rPr/>
-              <a:t> — כל עוד תנאי מתקיים</a:t>
-            </a:r>
-          </a:p>
-          <a:p>
-            <a:pPr lvl="0" algn="r" rtl="1"/>
-            <a:r>
-              <a:rPr/>
-              <a:t>הבסיס לאוטומציה</a:t>
+              <a:t>wait</a:t>
+            </a:r>
+            <a:r>
+              <a:rPr/>
+              <a:t> לסיום</a:t>
+            </a:r>
+          </a:p>
+          <a:p>
+            <a:pPr lvl="0" algn="r" rtl="1"/>
+            <a:r>
+              <a:rPr/>
+              <a:t>בסיס לשלב הסריקה</a:t>
             </a:r>
           </a:p>
         </p:txBody>
@@ -3903,7 +4108,7 @@
             </a:pPr>
             <a:r>
               <a:rPr/>
-              <a:t>פונקציות ומודולים</a:t>
+              <a:t>Python — טיפוסים</a:t>
             </a:r>
           </a:p>
         </p:txBody>
@@ -3926,42 +4131,96 @@
             <a:pPr lvl="0" algn="r" rtl="1"/>
             <a:r>
               <a:rPr b="1"/>
-              <a:t>פונקציה</a:t>
-            </a:r>
-            <a:r>
-              <a:rPr/>
-              <a:t> — אריזת קוד לשימוש חוזר</a:t>
-            </a:r>
-          </a:p>
-          <a:p>
-            <a:pPr lvl="0" algn="r" rtl="1"/>
+              <a:t>String</a:t>
+            </a:r>
+            <a:r>
+              <a:rPr/>
+              <a:t> </a:t>
+            </a:r>
             <a:r>
               <a:rPr>
                 <a:latin typeface="Courier"/>
               </a:rPr>
-              <a:t>def scan_port(ip, port):</a:t>
-            </a:r>
-          </a:p>
-          <a:p>
-            <a:pPr lvl="0" algn="r" rtl="1"/>
+              <a:t>"nmap"</a:t>
+            </a:r>
+            <a:r>
+              <a:rPr/>
+              <a:t> · </a:t>
+            </a:r>
             <a:r>
               <a:rPr b="1"/>
-              <a:t>socket</a:t>
-            </a:r>
-            <a:r>
-              <a:rPr/>
-              <a:t> — תקשורת רשת</a:t>
+              <a:t>Integer</a:t>
+            </a:r>
+            <a:r>
+              <a:rPr/>
+              <a:t> </a:t>
+            </a:r>
+            <a:r>
+              <a:rPr>
+                <a:latin typeface="Courier"/>
+              </a:rPr>
+              <a:t>443</a:t>
             </a:r>
           </a:p>
           <a:p>
             <a:pPr lvl="0" algn="r" rtl="1"/>
             <a:r>
               <a:rPr b="1"/>
-              <a:t>sys</a:t>
-            </a:r>
-            <a:r>
-              <a:rPr/>
-              <a:t> — ארגומנטים ומערכת</a:t>
+              <a:t>Float</a:t>
+            </a:r>
+            <a:r>
+              <a:rPr/>
+              <a:t> </a:t>
+            </a:r>
+            <a:r>
+              <a:rPr>
+                <a:latin typeface="Courier"/>
+              </a:rPr>
+              <a:t>2.5</a:t>
+            </a:r>
+            <a:r>
+              <a:rPr/>
+              <a:t> · </a:t>
+            </a:r>
+            <a:r>
+              <a:rPr b="1"/>
+              <a:t>Boolean</a:t>
+            </a:r>
+            <a:r>
+              <a:rPr/>
+              <a:t> </a:t>
+            </a:r>
+            <a:r>
+              <a:rPr>
+                <a:latin typeface="Courier"/>
+              </a:rPr>
+              <a:t>True</a:t>
+            </a:r>
+          </a:p>
+          <a:p>
+            <a:pPr lvl="0" algn="r" rtl="1"/>
+            <a:r>
+              <a:rPr/>
+              <a:t>f-strings: </a:t>
+            </a:r>
+            <a:r>
+              <a:rPr>
+                <a:latin typeface="Courier"/>
+              </a:rPr>
+              <a:t>f"Scan {ip}:{port}"</a:t>
+            </a:r>
+          </a:p>
+          <a:p>
+            <a:pPr lvl="0" algn="r" rtl="1"/>
+            <a:r>
+              <a:rPr>
+                <a:latin typeface="Courier"/>
+              </a:rPr>
+              <a:t>banner.split("/")</a:t>
+            </a:r>
+            <a:r>
+              <a:rPr/>
+              <a:t> — פרסינג פלט</a:t>
             </a:r>
           </a:p>
         </p:txBody>
@@ -4008,7 +4267,7 @@
             </a:pPr>
             <a:r>
               <a:rPr/>
-              <a:t>פרויקט: סורק פורטים</a:t>
+              <a:t>Python — מבני נתונים</a:t>
             </a:r>
           </a:p>
         </p:txBody>
@@ -4030,41 +4289,73 @@
           <a:p>
             <a:pPr lvl="0" algn="r" rtl="1"/>
             <a:r>
-              <a:rPr/>
-              <a:t>יוצר socket מסוג TCP לכל פורט</a:t>
-            </a:r>
-          </a:p>
-          <a:p>
-            <a:pPr lvl="0" algn="r" rtl="1"/>
+              <a:rPr b="1"/>
+              <a:t>List</a:t>
+            </a:r>
+            <a:r>
+              <a:rPr/>
+              <a:t> </a:t>
+            </a:r>
             <a:r>
               <a:rPr>
                 <a:latin typeface="Courier"/>
               </a:rPr>
-              <a:t>connect_ex()</a:t>
-            </a:r>
-            <a:r>
-              <a:rPr/>
-              <a:t> מחזיר 0 = פורט פתוח</a:t>
-            </a:r>
-          </a:p>
-          <a:p>
-            <a:pPr lvl="0" algn="r" rtl="1"/>
-            <a:r>
-              <a:rPr/>
-              <a:t>לולאה על טווח 1–1024</a:t>
-            </a:r>
-          </a:p>
-          <a:p>
-            <a:pPr lvl="0" algn="r" rtl="1"/>
+              <a:t>[ ]</a:t>
+            </a:r>
+            <a:r>
+              <a:rPr/>
+              <a:t> — מסודר, משתנה</a:t>
+            </a:r>
+          </a:p>
+          <a:p>
+            <a:pPr lvl="0" algn="r" rtl="1"/>
+            <a:r>
+              <a:rPr b="1"/>
+              <a:t>Dictionary</a:t>
+            </a:r>
+            <a:r>
+              <a:rPr/>
+              <a:t> </a:t>
+            </a:r>
             <a:r>
               <a:rPr>
                 <a:latin typeface="Courier"/>
               </a:rPr>
-              <a:t>try/except</a:t>
-            </a:r>
-            <a:r>
-              <a:rPr/>
-              <a:t> לטיפול בשגיאות ו-Ctrl+C</a:t>
+              <a:t>{80: "HTTP"}</a:t>
+            </a:r>
+            <a:r>
+              <a:rPr/>
+              <a:t> — מיפוי</a:t>
+            </a:r>
+          </a:p>
+          <a:p>
+            <a:pPr lvl="0" algn="r" rtl="1"/>
+            <a:r>
+              <a:rPr b="1"/>
+              <a:t>Tuple</a:t>
+            </a:r>
+            <a:r>
+              <a:rPr/>
+              <a:t> </a:t>
+            </a:r>
+            <a:r>
+              <a:rPr>
+                <a:latin typeface="Courier"/>
+              </a:rPr>
+              <a:t>( )</a:t>
+            </a:r>
+            <a:r>
+              <a:rPr/>
+              <a:t> — קבוע</a:t>
+            </a:r>
+          </a:p>
+          <a:p>
+            <a:pPr lvl="0" algn="r" rtl="1"/>
+            <a:r>
+              <a:rPr>
+                <a:latin typeface="Courier"/>
+              </a:rPr>
+              <a:t>services.get(port, "Unknown")</a:t>
             </a:r>
           </a:p>
         </p:txBody>
@@ -4111,7 +4402,7 @@
             </a:pPr>
             <a:r>
               <a:rPr/>
-              <a:t>הקוד המרכזי</a:t>
+              <a:t>Python — תנאים, לולאות, פונקציות</a:t>
             </a:r>
           </a:p>
         </p:txBody>
@@ -4131,181 +4422,39 @@
           <a:bodyPr/>
           <a:lstStyle/>
           <a:p>
-            <a:pPr lvl="0" indent="0" algn="r" rtl="1">
-              <a:buNone/>
-            </a:pPr>
+            <a:pPr lvl="0" algn="r" rtl="1"/>
             <a:r>
               <a:rPr>
                 <a:latin typeface="Courier"/>
               </a:rPr>
-              <a:t>s </a:t>
-            </a:r>
-            <a:r>
-              <a:rPr>
-                <a:solidFill>
-                  <a:srgbClr val="666666"/>
-                </a:solidFill>
-                <a:latin typeface="Courier"/>
-              </a:rPr>
-              <a:t>=</a:t>
-            </a:r>
+              <a:t>if / elif / else</a:t>
+            </a:r>
+          </a:p>
+          <a:p>
+            <a:pPr lvl="0" algn="r" rtl="1"/>
             <a:r>
               <a:rPr>
                 <a:latin typeface="Courier"/>
               </a:rPr>
-              <a:t> socket.socket(socket.AF_INET,</a:t>
-            </a:r>
-            <a:br/>
+              <a:t>for port in range(1, 1025)</a:t>
+            </a:r>
+          </a:p>
+          <a:p>
+            <a:pPr lvl="0" algn="r" rtl="1"/>
             <a:r>
               <a:rPr>
                 <a:latin typeface="Courier"/>
               </a:rPr>
-              <a:t>                  socket.SOCK_STREAM)</a:t>
-            </a:r>
-            <a:br/>
+              <a:t>def scan_port(ip, port):</a:t>
+            </a:r>
+          </a:p>
+          <a:p>
+            <a:pPr lvl="0" algn="r" rtl="1"/>
             <a:r>
               <a:rPr>
                 <a:latin typeface="Courier"/>
               </a:rPr>
-              <a:t>s.settimeout(</a:t>
-            </a:r>
-            <a:r>
-              <a:rPr>
-                <a:solidFill>
-                  <a:srgbClr val="40A070"/>
-                </a:solidFill>
-                <a:latin typeface="Courier"/>
-              </a:rPr>
-              <a:t>0.5</a:t>
-            </a:r>
-            <a:r>
-              <a:rPr>
-                <a:latin typeface="Courier"/>
-              </a:rPr>
-              <a:t>)</a:t>
-            </a:r>
-            <a:br/>
-            <a:r>
-              <a:rPr b="1">
-                <a:solidFill>
-                  <a:srgbClr val="007020"/>
-                </a:solidFill>
-                <a:latin typeface="Courier"/>
-              </a:rPr>
-              <a:t>if</a:t>
-            </a:r>
-            <a:r>
-              <a:rPr>
-                <a:latin typeface="Courier"/>
-              </a:rPr>
-              <a:t> s.connect_ex((target, port)) </a:t>
-            </a:r>
-            <a:r>
-              <a:rPr>
-                <a:solidFill>
-                  <a:srgbClr val="666666"/>
-                </a:solidFill>
-                <a:latin typeface="Courier"/>
-              </a:rPr>
-              <a:t>==</a:t>
-            </a:r>
-            <a:r>
-              <a:rPr>
-                <a:latin typeface="Courier"/>
-              </a:rPr>
-              <a:t> </a:t>
-            </a:r>
-            <a:r>
-              <a:rPr>
-                <a:solidFill>
-                  <a:srgbClr val="40A070"/>
-                </a:solidFill>
-                <a:latin typeface="Courier"/>
-              </a:rPr>
-              <a:t>0</a:t>
-            </a:r>
-            <a:r>
-              <a:rPr>
-                <a:latin typeface="Courier"/>
-              </a:rPr>
-              <a:t>:</a:t>
-            </a:r>
-            <a:br/>
-            <a:r>
-              <a:rPr>
-                <a:latin typeface="Courier"/>
-              </a:rPr>
-              <a:t>    </a:t>
-            </a:r>
-            <a:r>
-              <a:rPr>
-                <a:solidFill>
-                  <a:srgbClr val="008000"/>
-                </a:solidFill>
-                <a:latin typeface="Courier"/>
-              </a:rPr>
-              <a:t>print</a:t>
-            </a:r>
-            <a:r>
-              <a:rPr>
-                <a:latin typeface="Courier"/>
-              </a:rPr>
-              <a:t>(</a:t>
-            </a:r>
-            <a:r>
-              <a:rPr>
-                <a:solidFill>
-                  <a:srgbClr val="BB6688"/>
-                </a:solidFill>
-                <a:latin typeface="Courier"/>
-              </a:rPr>
-              <a:t>f"[+] Port </a:t>
-            </a:r>
-            <a:r>
-              <a:rPr>
-                <a:solidFill>
-                  <a:srgbClr val="4070A0"/>
-                </a:solidFill>
-                <a:latin typeface="Courier"/>
-              </a:rPr>
-              <a:t>{</a:t>
-            </a:r>
-            <a:r>
-              <a:rPr>
-                <a:latin typeface="Courier"/>
-              </a:rPr>
-              <a:t>port</a:t>
-            </a:r>
-            <a:r>
-              <a:rPr>
-                <a:solidFill>
-                  <a:srgbClr val="4070A0"/>
-                </a:solidFill>
-                <a:latin typeface="Courier"/>
-              </a:rPr>
-              <a:t>}</a:t>
-            </a:r>
-            <a:r>
-              <a:rPr>
-                <a:solidFill>
-                  <a:srgbClr val="BB6688"/>
-                </a:solidFill>
-                <a:latin typeface="Courier"/>
-              </a:rPr>
-              <a:t> OPEN"</a:t>
-            </a:r>
-            <a:r>
-              <a:rPr>
-                <a:latin typeface="Courier"/>
-              </a:rPr>
-              <a:t>)</a:t>
-            </a:r>
-            <a:br/>
-            <a:r>
-              <a:rPr>
-                <a:latin typeface="Courier"/>
-              </a:rPr>
-              <a:t>s.close()</a:t>
+              <a:t>import socket, sys</a:t>
             </a:r>
           </a:p>
         </p:txBody>

</xml_diff>